<commit_message>
IdentityWallet: theme toggle, one-click start scripts, docs update
</commit_message>
<xml_diff>
--- a/Java Projects/identity-wallet/docs/IdentityWallet_Presentation.pptx
+++ b/Java Projects/identity-wallet/docs/IdentityWallet_Presentation.pptx
@@ -124,7 +124,7 @@
   <p:extLst>
     <p:ext uri="{521415D9-36F7-43E2-AB2F-B90AF26B5E84}">
       <p14:sectionLst xmlns:p14="http://schemas.microsoft.com/office/powerpoint/2010/main">
-        <p14:section name="Introduction" id="{3e63c2cb-f1a6-8284-e0a0-abc5c94c440e}">
+        <p14:section name="Introduction" id="{b854156d-b967-98f0-dd4e-dc21d24a7bf8}">
           <p14:sldIdLst>
             <p14:sldId id="256"/>
             <p14:sldId id="257"/>
@@ -132,7 +132,7 @@
             <p14:sldId id="259"/>
           </p14:sldIdLst>
         </p14:section>
-        <p14:section name="Solution" id="{6fd20a6d-0d76-1615-5d90-e8b5d9c0b0df}">
+        <p14:section name="Solution" id="{23ae1fc1-fd8c-a7eb-c9d3-b82a9f42db2e}">
           <p14:sldIdLst>
             <p14:sldId id="260"/>
             <p14:sldId id="261"/>
@@ -142,21 +142,21 @@
             <p14:sldId id="265"/>
           </p14:sldIdLst>
         </p14:section>
-        <p14:section name="Security" id="{001cbb9a-987e-4229-6027-8cdc422e8ed6}">
+        <p14:section name="Security" id="{66345a04-7ae2-0b61-da21-c0ff890b1d62}">
           <p14:sldIdLst>
             <p14:sldId id="266"/>
             <p14:sldId id="267"/>
             <p14:sldId id="268"/>
           </p14:sldIdLst>
         </p14:section>
-        <p14:section name="Results" id="{ea474013-0cc2-e62c-76d1-ed4317facee3}">
+        <p14:section name="Results" id="{2b8a9831-4a78-2178-4349-e9f67d0051f0}">
           <p14:sldIdLst>
             <p14:sldId id="269"/>
             <p14:sldId id="270"/>
             <p14:sldId id="271"/>
           </p14:sldIdLst>
         </p14:section>
-        <p14:section name="Conclusion" id="{5ea9a337-fc3c-e3bd-ee8e-79e73af6671c}">
+        <p14:section name="Conclusion" id="{757285e1-aee4-8575-3249-bc101cc38d5c}">
           <p14:sldIdLst>
             <p14:sldId id="272"/>
             <p14:sldId id="273"/>

</xml_diff>